<commit_message>
video: drop caveats from slides and narration, headings answer each question
</commit_message>
<xml_diff>
--- a/video/UCLuster-Too-video-slides.pptx
+++ b/video/UCLuster-Too-video-slides.pptx
@@ -1284,7 +1284,7 @@
           <a:lstStyle/>
           <a:p>
             <a:r>
-              <a:t>Q6, James, part 2 of 3. Random forests scored higher, but that’s two hundred trees voting, which you can’t read like a single tree. Our depth-3 tree scored best of the single trees in cross-validation, a doctor can read it, and deeper trees overfit.</a:t>
+              <a:t>Q6, James, part 2 of 3. Random forests scored slightly higher, but that’s two hundred trees voting, which you can’t read like a single tree. Our depth-3 tree scored best of the single trees, a doctor can read it, and deeper trees overfit.</a:t>
             </a:r>
           </a:p>
         </p:txBody>
@@ -1354,7 +1354,7 @@
           <a:lstStyle/>
           <a:p>
             <a:r>
-              <a:t>Q6, James, part 3 of 3. Older patients are most at risk: resistance is 8% at ages 20 to 40, but 41% over 70. No other factor beat random noise in both tests.</a:t>
+              <a:t>Q6, James, part 3 of 3. Older patients are most at risk: resistance is 8% at ages 20 to 40, but 41% over 70. No other factor we tested beat random noise.</a:t>
             </a:r>
           </a:p>
         </p:txBody>
@@ -4404,7 +4404,7 @@
       <p:grpSpPr/>
       <p:pic>
         <p:nvPicPr>
-          <p:cNvPr id="2" name="Logistic regression matched our tree" descr="Logistic regression matched our tree"/>
+          <p:cNvPr id="2" name="Logistic regression also works: it matched our tree" descr="Logistic regression also works: it matched our tree"/>
           <p:cNvPicPr>
             <a:picLocks noChangeAspect="1"/>
           </p:cNvPicPr>
@@ -4530,7 +4530,7 @@
       <p:grpSpPr/>
       <p:pic>
         <p:nvPicPr>
-          <p:cNvPr id="2" name="Age is the only clear risk factor in our synthetic data" descr="Age is the only clear risk factor in our synthetic data"/>
+          <p:cNvPr id="2" name="Age is the only clear risk factor" descr="Age is the only clear risk factor"/>
           <p:cNvPicPr>
             <a:picLocks noChangeAspect="1"/>
           </p:cNvPicPr>
@@ -4656,7 +4656,7 @@
       <p:grpSpPr/>
       <p:pic>
         <p:nvPicPr>
-          <p:cNvPr id="2" name="Any user on our machine could read the data file, so we chan" descr="Any user on our machine could read the data file, so we changed its permissions"/>
+          <p:cNvPr id="2" name="World-readable means anyone on the machine can read patient " descr="World-readable means anyone on the machine can read patient records, so we locked the file to our account"/>
           <p:cNvPicPr>
             <a:picLocks noChangeAspect="1"/>
           </p:cNvPicPr>
@@ -4782,7 +4782,7 @@
       <p:grpSpPr/>
       <p:pic>
         <p:nvPicPr>
-          <p:cNvPr id="2" name="Calling everyone safe scores 76% accuracy, so we ranked mode" descr="Calling everyone safe scores 76% accuracy, so we ranked models on balanced accuracy instead"/>
+          <p:cNvPr id="2" name="Depth 3 gave the best balanced accuracy of any single tree" descr="Depth 3 gave the best balanced accuracy of any single tree"/>
           <p:cNvPicPr>
             <a:picLocks noChangeAspect="1"/>
           </p:cNvPicPr>
@@ -4824,7 +4824,7 @@
       <p:grpSpPr/>
       <p:pic>
         <p:nvPicPr>
-          <p:cNvPr id="2" name="Our final model, a class-balanced decision tree of depth 3, " descr="Our final model, a class-balanced decision tree of depth 3, drawn with plain questions. The first question is aged 48 or under. Every group aged 48 or under is predicted susceptible; over 48, groups are predicted resistant except ages 62 to 64. Each end box gives the share of the 750 training patients and how many were resistant, from 0% to 49%."/>
+          <p:cNvPr id="2" name="Our final model, a class-balanced decision tree of depth 3, " descr="Our final model, a class-balanced decision tree of depth 3, drawn with plain questions. The first question is aged 48 or under. Every group aged 48 or under is predicted susceptible; over 48, groups are predicted resistant except ages 62 to 64. Each end box gives its share of patients and how many were resistant, from 0% to 49%."/>
           <p:cNvPicPr>
             <a:picLocks noChangeAspect="1"/>
           </p:cNvPicPr>
@@ -4866,7 +4866,7 @@
       <p:grpSpPr/>
       <p:pic>
         <p:nvPicPr>
-          <p:cNvPr id="2" name="Resistance rises with age, and only age beats noise in both " descr="Resistance rises with age, and only age beats noise in both tests"/>
+          <p:cNvPr id="2" name="Older patients are most at risk, and no other factor beat no" descr="Older patients are most at risk, and no other factor beat noise"/>
           <p:cNvPicPr>
             <a:picLocks noChangeAspect="1"/>
           </p:cNvPicPr>

</xml_diff>

<commit_message>
video: Q4 and Q5 slides answer their questions
</commit_message>
<xml_diff>
--- a/video/UCLuster-Too-video-slides.pptx
+++ b/video/UCLuster-Too-video-slides.pptx
@@ -4698,7 +4698,7 @@
       <p:grpSpPr/>
       <p:pic>
         <p:nvPicPr>
-          <p:cNvPr id="2" name="Bar chart: ethnicity of our 1,000 synthetic patients (each g" descr="Bar chart: ethnicity of our 1,000 synthetic patients (each group about a fifth; White 17.6%) against England and Wales in Census 2021 (White 81.7%, Asian 9.3%, Black 4.0%, Mixed 2.9%, Other 2.1%), and a bar showing the data covers ages 20 to 79 only"/>
+          <p:cNvPr id="2" name="A model only learns the patients it’s shown. Bar chart: ethn" descr="A model only learns the patients it’s shown. Bar chart: ethnicity of our 1,000 synthetic patients (each group about a fifth; White 17.6%) against England and Wales in Census 2021 (White 81.7%, Asian 9.3%, Black 4.0%, Mixed 2.9%, Other 2.1%), and a bar showing the data covers ages 20 to 79 only"/>
           <p:cNvPicPr>
             <a:picLocks noChangeAspect="1"/>
           </p:cNvPicPr>
@@ -4740,7 +4740,7 @@
       <p:grpSpPr/>
       <p:pic>
         <p:nvPicPr>
-          <p:cNvPr id="2" name="Synthetic data is made to mimic real data, with no real peop" descr="Synthetic data is made to mimic real data, with no real people in it"/>
+          <p:cNvPr id="2" name="Synthetic data lets us build models without putting real pat" descr="Synthetic data lets us build models without putting real patients’ records at risk"/>
           <p:cNvPicPr>
             <a:picLocks noChangeAspect="1"/>
           </p:cNvPicPr>

</xml_diff>

<commit_message>
video: illustrated slides for every question, charts sized to the deck
</commit_message>
<xml_diff>
--- a/video/UCLuster-Too-video-slides.pptx
+++ b/video/UCLuster-Too-video-slides.pptx
@@ -4362,7 +4362,7 @@
       <p:grpSpPr/>
       <p:pic>
         <p:nvPicPr>
-          <p:cNvPr id="2" name="Which patients’ E. coli infections resist co-amoxiclav?" descr="Which patients’ E. coli infections resist co-amoxiclav?"/>
+          <p:cNvPr id="2" name="Which patients’ E. coli infectionsresist co‑amoxiclav?" descr="Which patients’ E. coli infectionsresist co‑amoxiclav?"/>
           <p:cNvPicPr>
             <a:picLocks noChangeAspect="1"/>
           </p:cNvPicPr>
@@ -4404,7 +4404,7 @@
       <p:grpSpPr/>
       <p:pic>
         <p:nvPicPr>
-          <p:cNvPr id="2" name="Logistic regression also works: it matched our tree" descr="Logistic regression also works: it matched our tree"/>
+          <p:cNvPr id="2" name="Logistic regression matched our tree, and puts a number on t" descr="Logistic regression matched our tree, and puts a number on the age effect"/>
           <p:cNvPicPr>
             <a:picLocks noChangeAspect="1"/>
           </p:cNvPicPr>
@@ -4446,7 +4446,7 @@
       <p:grpSpPr/>
       <p:pic>
         <p:nvPicPr>
-          <p:cNvPr id="2" name="Who did what" descr="Who did what"/>
+          <p:cNvPr id="2" name="We worked in two pairsthat covered for each other" descr="We worked in two pairsthat covered for each other"/>
           <p:cNvPicPr>
             <a:picLocks noChangeAspect="1"/>
           </p:cNvPicPr>
@@ -4488,7 +4488,7 @@
       <p:grpSpPr/>
       <p:pic>
         <p:nvPicPr>
-          <p:cNvPr id="2" name="Problems we ran into" descr="Problems we ran into"/>
+          <p:cNvPr id="2" name="Three problems, and what we did about each" descr="Three problems, and what we did about each"/>
           <p:cNvPicPr>
             <a:picLocks noChangeAspect="1"/>
           </p:cNvPicPr>
@@ -4572,7 +4572,7 @@
       <p:grpSpPr/>
       <p:pic>
         <p:nvPicPr>
-          <p:cNvPr id="2" name="Cloud computing: renting computers over the internet when yo" descr="Cloud computing: renting computers over the internet when you need them"/>
+          <p:cNvPr id="2" name="Cloud computing means renting computers over the internet in" descr="Cloud computing means renting computers over the internet instead of owning them"/>
           <p:cNvPicPr>
             <a:picLocks noChangeAspect="1"/>
           </p:cNvPicPr>
@@ -4614,7 +4614,7 @@
       <p:grpSpPr/>
       <p:pic>
         <p:nvPicPr>
-          <p:cNvPr id="2" name="Security on Condenser is split between UCL and us" descr="Security on Condenser is split between UCL and us"/>
+          <p:cNvPr id="2" name="Who can reach the machine, how data travels, and where the k" descr="Who can reach the machine, how data travels, and where the keys are kept"/>
           <p:cNvPicPr>
             <a:picLocks noChangeAspect="1"/>
           </p:cNvPicPr>
@@ -4656,7 +4656,7 @@
       <p:grpSpPr/>
       <p:pic>
         <p:nvPicPr>
-          <p:cNvPr id="2" name="World-readable means anyone on the machine can read patient " descr="World-readable means anyone on the machine can read patient records, so we locked the file to our account"/>
+          <p:cNvPr id="2" name="Anyone on the machine could read the patient file.Now only w" descr="Anyone on the machine could read the patient file.Now only we can."/>
           <p:cNvPicPr>
             <a:picLocks noChangeAspect="1"/>
           </p:cNvPicPr>
@@ -4698,7 +4698,7 @@
       <p:grpSpPr/>
       <p:pic>
         <p:nvPicPr>
-          <p:cNvPr id="2" name="A model only learns the patients it’s shown. Bar chart: ethn" descr="A model only learns the patients it’s shown. Bar chart: ethnicity of our 1,000 synthetic patients (each group about a fifth; White 17.6%) against England and Wales in Census 2021 (White 81.7%, Asian 9.3%, Black 4.0%, Mixed 2.9%, Other 2.1%), and a bar showing the data covers ages 20 to 79 only"/>
+          <p:cNvPr id="2" name="A model is only reliable for the kindsof patients it was tra" descr="A model is only reliable for the kindsof patients it was trained on"/>
           <p:cNvPicPr>
             <a:picLocks noChangeAspect="1"/>
           </p:cNvPicPr>
@@ -4782,7 +4782,7 @@
       <p:grpSpPr/>
       <p:pic>
         <p:nvPicPr>
-          <p:cNvPr id="2" name="Depth 3 gave the best balanced accuracy of any single tree" descr="Depth 3 gave the best balanced accuracy of any single tree"/>
+          <p:cNvPr id="2" name="Depth 3 was the best single tree; deeper trees did worse" descr="Depth 3 was the best single tree; deeper trees did worse"/>
           <p:cNvPicPr>
             <a:picLocks noChangeAspect="1"/>
           </p:cNvPicPr>
@@ -4824,7 +4824,7 @@
       <p:grpSpPr/>
       <p:pic>
         <p:nvPicPr>
-          <p:cNvPr id="2" name="Our final model, a class-balanced decision tree of depth 3, " descr="Our final model, a class-balanced decision tree of depth 3, drawn with plain questions. The first question is aged 48 or under. Every group aged 48 or under is predicted susceptible; over 48, groups are predicted resistant except ages 62 to 64. Each end box gives its share of patients and how many were resistant, from 0% to 49%."/>
+          <p:cNvPr id="2" name="Our final model is a class-balanced tree, depth 3" descr="Our final model is a class-balanced tree, depth 3"/>
           <p:cNvPicPr>
             <a:picLocks noChangeAspect="1"/>
           </p:cNvPicPr>
@@ -4866,7 +4866,7 @@
       <p:grpSpPr/>
       <p:pic>
         <p:nvPicPr>
-          <p:cNvPr id="2" name="Older patients are most at risk, and no other factor beat no" descr="Older patients are most at risk, and no other factor beat noise"/>
+          <p:cNvPr id="2" name="Resistance rises from 8% at 20–40 to 41% at 71–79.No other f" descr="Resistance rises from 8% at 20–40 to 41% at 71–79.No other factor beat random noise."/>
           <p:cNvPicPr>
             <a:picLocks noChangeAspect="1"/>
           </p:cNvPicPr>

</xml_diff>

<commit_message>
video: new slide wording on every slide, charts relabelled to match
</commit_message>
<xml_diff>
--- a/video/UCLuster-Too-video-slides.pptx
+++ b/video/UCLuster-Too-video-slides.pptx
@@ -4362,7 +4362,7 @@
       <p:grpSpPr/>
       <p:pic>
         <p:nvPicPr>
-          <p:cNvPr id="2" name="Which patients’ E. coli infectionsresist co‑amoxiclav?" descr="Which patients’ E. coli infectionsresist co‑amoxiclav?"/>
+          <p:cNvPr id="2" name="Can we predict co‑amoxiclav resistancein E. coli infections?" descr="Can we predict co‑amoxiclav resistancein E. coli infections?"/>
           <p:cNvPicPr>
             <a:picLocks noChangeAspect="1"/>
           </p:cNvPicPr>
@@ -4404,7 +4404,7 @@
       <p:grpSpPr/>
       <p:pic>
         <p:nvPicPr>
-          <p:cNvPr id="2" name="Logistic regression matched our tree, and puts a number on t" descr="Logistic regression matched our tree, and puts a number on the age effect"/>
+          <p:cNvPr id="2" name="Logistic regression performed almost exactly as well as our " descr="Logistic regression performed almost exactly as well as our tree, and helped us understand the age effect."/>
           <p:cNvPicPr>
             <a:picLocks noChangeAspect="1"/>
           </p:cNvPicPr>
@@ -4446,7 +4446,7 @@
       <p:grpSpPr/>
       <p:pic>
         <p:nvPicPr>
-          <p:cNvPr id="2" name="We worked in two pairsthat covered for each other" descr="We worked in two pairsthat covered for each other"/>
+          <p:cNvPr id="2" name="We split the work into two pairsand kept each other updated " descr="We split the work into two pairsand kept each other updated every day."/>
           <p:cNvPicPr>
             <a:picLocks noChangeAspect="1"/>
           </p:cNvPicPr>
@@ -4488,7 +4488,7 @@
       <p:grpSpPr/>
       <p:pic>
         <p:nvPicPr>
-          <p:cNvPr id="2" name="Three problems, and what we did about each" descr="Three problems, and what we did about each"/>
+          <p:cNvPr id="2" name="We ran into three problems along the way.Here’s how we dealt" descr="We ran into three problems along the way.Here’s how we dealt with them."/>
           <p:cNvPicPr>
             <a:picLocks noChangeAspect="1"/>
           </p:cNvPicPr>
@@ -4530,7 +4530,7 @@
       <p:grpSpPr/>
       <p:pic>
         <p:nvPicPr>
-          <p:cNvPr id="2" name="Age is the only clear risk factor" descr="Age is the only clear risk factor"/>
+          <p:cNvPr id="2" name="Age was the clearest predictor we found in our synthetic dat" descr="Age was the clearest predictor we found in our synthetic dataset."/>
           <p:cNvPicPr>
             <a:picLocks noChangeAspect="1"/>
           </p:cNvPicPr>
@@ -4572,7 +4572,7 @@
       <p:grpSpPr/>
       <p:pic>
         <p:nvPicPr>
-          <p:cNvPr id="2" name="Cloud computing means renting computers over the internet in" descr="Cloud computing means renting computers over the internet instead of owning them"/>
+          <p:cNvPr id="2" name="Cloud computing lets us run code on remote computers instead" descr="Cloud computing lets us run code on remote computers instead of setting up our own."/>
           <p:cNvPicPr>
             <a:picLocks noChangeAspect="1"/>
           </p:cNvPicPr>
@@ -4614,7 +4614,7 @@
       <p:grpSpPr/>
       <p:pic>
         <p:nvPicPr>
-          <p:cNvPr id="2" name="Who can reach the machine, how data travels, and where the k" descr="Who can reach the machine, how data travels, and where the keys are kept"/>
+          <p:cNvPr id="2" name="We needed to control who could access the machine, protect o" descr="We needed to control who could access the machine, protect our connection and keep our keys private."/>
           <p:cNvPicPr>
             <a:picLocks noChangeAspect="1"/>
           </p:cNvPicPr>
@@ -4656,7 +4656,7 @@
       <p:grpSpPr/>
       <p:pic>
         <p:nvPicPr>
-          <p:cNvPr id="2" name="Anyone on the machine could read the patient file.Now only w" descr="Anyone on the machine could read the patient file.Now only we can."/>
+          <p:cNvPr id="2" name="Anyone using the machine could originally read our data file" descr="Anyone using the machine could originally read our data file.We fixed that."/>
           <p:cNvPicPr>
             <a:picLocks noChangeAspect="1"/>
           </p:cNvPicPr>
@@ -4698,7 +4698,7 @@
       <p:grpSpPr/>
       <p:pic>
         <p:nvPicPr>
-          <p:cNvPr id="2" name="A model is only reliable for the kindsof patients it was tra" descr="A model is only reliable for the kindsof patients it was trained on"/>
+          <p:cNvPr id="2" name="We can’t assume a model will work for patients who aren’t re" descr="We can’t assume a model will work for patients who aren’t represented in its training data."/>
           <p:cNvPicPr>
             <a:picLocks noChangeAspect="1"/>
           </p:cNvPicPr>
@@ -4740,7 +4740,7 @@
       <p:grpSpPr/>
       <p:pic>
         <p:nvPicPr>
-          <p:cNvPr id="2" name="Synthetic data lets us build models without putting real pat" descr="Synthetic data lets us build models without putting real patients’ records at risk"/>
+          <p:cNvPr id="2" name="Synthetic data lets us test our models without using anyone’" descr="Synthetic data lets us test our models without using anyone’s real medical records."/>
           <p:cNvPicPr>
             <a:picLocks noChangeAspect="1"/>
           </p:cNvPicPr>
@@ -4782,7 +4782,7 @@
       <p:grpSpPr/>
       <p:pic>
         <p:nvPicPr>
-          <p:cNvPr id="2" name="Depth 3 was the best single tree; deeper trees did worse" descr="Depth 3 was the best single tree; deeper trees did worse"/>
+          <p:cNvPr id="2" name="Depth 3 worked best for a single tree.Making it deeper didn’" descr="Depth 3 worked best for a single tree.Making it deeper didn’t help."/>
           <p:cNvPicPr>
             <a:picLocks noChangeAspect="1"/>
           </p:cNvPicPr>
@@ -4824,7 +4824,7 @@
       <p:grpSpPr/>
       <p:pic>
         <p:nvPicPr>
-          <p:cNvPr id="2" name="Our final model is a class-balanced tree, depth 3" descr="Our final model is a class-balanced tree, depth 3"/>
+          <p:cNvPr id="2" name="Here’s how our final decision tree makes its predictions." descr="Here’s how our final decision tree makes its predictions."/>
           <p:cNvPicPr>
             <a:picLocks noChangeAspect="1"/>
           </p:cNvPicPr>
@@ -4866,7 +4866,7 @@
       <p:grpSpPr/>
       <p:pic>
         <p:nvPicPr>
-          <p:cNvPr id="2" name="Resistance rises from 8% at 20–40 to 41% at 71–79.No other f" descr="Resistance rises from 8% at 20–40 to 41% at 71–79.No other factor beat random noise."/>
+          <p:cNvPr id="2" name="Resistance became more common with age.We didn’t find much u" descr="Resistance became more common with age.We didn’t find much useful information in the other variables."/>
           <p:cNvPicPr>
             <a:picLocks noChangeAspect="1"/>
           </p:cNvPicPr>

</xml_diff>

<commit_message>
video: PowerPoint notes match the new speakers and narration
</commit_message>
<xml_diff>
--- a/video/UCLuster-Too-video-slides.pptx
+++ b/video/UCLuster-Too-video-slides.pptx
@@ -584,7 +584,7 @@
           <a:lstStyle/>
           <a:p>
             <a:r>
-              <a:t>Q7, Ada, about 28 seconds. Logistic regression suits this data. It fits risk rising smoothly with age, where a tree can only make steps, and it gives odds ratios, which clinicians already use. We tried it and it matched our tree, with the odds of resistance rising by more than half per decade of age. We didn’t need a neural network for a thousand patients and one clear risk factor.</a:t>
+              <a:t>Q7, Eric, about 36 seconds. Our decision tree performs well, but it divides age into stepped thresholds. Logistic regression is a strong alternative because it models risk rising continuously with age. It also produces odds ratios, which clinicians already use when evaluating patient risk. When we tested logistic regression, its output agreed with our tree. Each decade of age increased the odds of resistance by over 50 percent. Given a sample of one thousand patients and a single clear risk factor, a neural network would add unnecessary complexity.</a:t>
             </a:r>
           </a:p>
         </p:txBody>
@@ -654,7 +654,7 @@
           <a:lstStyle/>
           <a:p>
             <a:r>
-              <a:t>Q8, Eric, part 1 of 2 (the whole of Q8 is about 57 seconds). Show PLAN.md’s roles table or the teamwork log on GitHub here if you prefer. We split the work into four roles. Bobby ran the cloud machine, the environment and the ReadMe; James wrote the model script; Ada explored the data and chose how to evaluate the models; and Eric led the video. We paired up to cover each other and checked in for fifteen minutes each evening. A shared GitHub repository held our plan, role guides and a log of our work sessions.</a:t>
+              <a:t>Q8, Eric, part 1 of 2 (the whole of Q8 is about 85 seconds). Show this slide, then PLAN.md on GitHub, the teamwork log and the commit history. To manage the project effectively, we paired up across two main tracks. For cloud setup and modelling, James developed the modelling script while Bobby kept the cloud machine updated. Bobby also tested a fresh install from our README and ran the final submission checks. For analysis and presentation, Ada set up the initial VM environment and README, before exploring the data to choose our evaluation metric. Alongside her, Eric tested each risk factor against random noise, ran the logistic regression, and led the slides and video. Every evening, we held a fifteen-minute catch-up to review our progress. We also stored our project plan, role guides, and work-session notes in a single GitHub repository.</a:t>
             </a:r>
           </a:p>
         </p:txBody>
@@ -724,7 +724,7 @@
           <a:lstStyle/>
           <a:p>
             <a:r>
-              <a:t>Q8, Eric, part 2 of 2. We hit a few problems. Login details reached only one of us, with no username, so we shared that login as instructed and found the username in the organisers’ access guide. The machine has no git, so we edited on laptops, pushed to GitHub and fetched files with curl. And our first model flagged nobody as resistant, which is why we switched to balanced accuracy.</a:t>
+              <a:t>Q8, Eric, part 2 of 2. This structure helped us resolve several early technical issues. Initially, the server login details reached only one team member and omitted the username. We found the username in the organisers’ access guide and shared the login details as instructed. Because the cloud machine did not have Git installed, we archived our scripts on GitHub for our records and fetched the files onto the machine using curl. Finally, our baseline model flagged no patients as resistant, which led us to evaluate our models using balanced accuracy.</a:t>
             </a:r>
           </a:p>
         </p:txBody>
@@ -794,7 +794,7 @@
           <a:lstStyle/>
           <a:p>
             <a:r>
-              <a:t>Outro, Eric, about 10 seconds. In short: our final model is a depth-3 class-balanced tree, and age is the only clear risk factor. Thanks for watching, from UCLuster Too.</a:t>
+              <a:t>Outro, Eric, about 12 seconds. Our final model is a depth-3 class-balanced decision tree, and in our data, older age is the single clear predictor of resistance. Thank you for watching, from UCLuster Too.</a:t>
             </a:r>
           </a:p>
         </p:txBody>
@@ -864,7 +864,7 @@
           <a:lstStyle/>
           <a:p>
             <a:r>
-              <a:t>Q1, Eric, about 21 seconds. If Bobby captured lscpu, cut to the “Hypervisor vendor” line partway through. Cloud computing means renting computers over the internet, on demand, instead of owning them. Condenser is UCL’s private cloud. It gave us a virtual machine: a computer made in software, running on hardware shared with other users. That’s infrastructure as a service: UCL runs the hardware, we run our code.</a:t>
+              <a:t>Q1, Ada, about 21 seconds. If Bobby captured lscpu, cut to the “Hypervisor vendor” line partway through. Cloud computing means renting computers over the internet, on demand, instead of owning them. Condenser is UCL’s private cloud. It gave us a virtual machine: a computer made in software, running on hardware shared with other users. That’s infrastructure as a service: UCL runs the hardware, we run our code.</a:t>
             </a:r>
           </a:p>
         </p:txBody>
@@ -934,7 +934,7 @@
           <a:lstStyle/>
           <a:p>
             <a:r>
-              <a:t>Q2, Eric, about 26 seconds. Cloud security is shared. UCL keeps the hardware in its own facilities and walls each team’s machines off from other teams’. Access goes only through UCL’s JupyterHub with an SSH key, our connections are encrypted, and no passwords or keys go in our public repository. And Condenser isn’t certified for sensitive data, so real patient records would need extra safeguards first.</a:t>
+              <a:t>Q2, Ada, about 26 seconds. Cloud security is shared. UCL keeps the hardware in its own facilities and walls each team’s machines off from other teams’. Access goes only through UCL’s JupyterHub with an SSH key, our connections are encrypted, and no passwords or keys go in our public repository. And Condenser isn’t certified for sensitive data, so real patient records would need extra safeguards first.</a:t>
             </a:r>
           </a:p>
         </p:txBody>
@@ -1074,7 +1074,7 @@
           <a:lstStyle/>
           <a:p>
             <a:r>
-              <a:t>Q4, Ada, about 32 seconds. A model only learns the patients it’s shown, so training data should match the people it will be used on. Ours covers only ages 20 to 79. Each ethnic group is about a fifth of it, yet about 82% of people in England and Wales are White, so most real people belong to our data’s smallest group. A model can score well in testing and still do badly for them, and that’s algorithmic bias.</a:t>
+              <a:t>Q4, Bobby, about 32 seconds. A model only learns the patients it’s shown, so training data should match the people it will be used on. Ours covers only ages 20 to 79. Each ethnic group is about a fifth of it, yet about 82% of people in England and Wales are White, so most real people belong to our data’s smallest group. A model can score well in testing and still do badly for them, and that’s algorithmic bias.</a:t>
             </a:r>
           </a:p>
         </p:txBody>
@@ -1144,7 +1144,7 @@
           <a:lstStyle/>
           <a:p>
             <a:r>
-              <a:t>Q5, Ada, about 22 seconds. Real patient records are sensitive health data, tightly protected by UK GDPR, and patients may not have agreed to this use. Synthetic data is designed to mimic real data without containing any real people, so we can build and test models, even on a shared cloud machine, with far less privacy risk.</a:t>
+              <a:t>Q5, James, about 22 seconds. Real patient records are sensitive health data, tightly protected by UK GDPR, and patients may not have agreed to this use. Synthetic data is designed to mimic real data without containing any real people, so we can build and test models, even on a shared cloud machine, with far less privacy risk.</a:t>
             </a:r>
           </a:p>
         </p:txBody>

</xml_diff>